<commit_message>
v5: apply Great's copy edits, show necks, price 9,900 (full 12,900)
Co-Authored-By: Claude Opus 5.5 <noreply@anthropic.com>
Claude-Session: https://claude.ai/code/session_01AU6SJgpQqjx92uQU48rYBV
</commit_message>
<xml_diff>
--- a/poster/ai-capcut-1day-v5.pptx
+++ b/poster/ai-capcut-1day-v5.pptx
@@ -992,8 +992,8 @@
         </p:nvSpPr>
         <p:spPr>
           <a:xfrm>
-            <a:off x="876300" y="2266950"/>
-            <a:ext cx="7877175" cy="828675"/>
+            <a:off x="1057275" y="2266950"/>
+            <a:ext cx="7877175" cy="1181100"/>
           </a:xfrm>
           <a:prstGeom prst="rect">
             <a:avLst/>
@@ -1011,15 +1011,15 @@
               <a:buNone/>
             </a:pPr>
             <a:r>
-              <a:rPr lang="en-US" sz="4950" dirty="0">
+              <a:rPr lang="en-US" sz="4950" b="1" dirty="0">
                 <a:solidFill>
                   <a:srgbClr val="FFFFFF"/>
                 </a:solidFill>
-                <a:latin typeface="LINE Seed Sans TH Heavy" pitchFamily="34" charset="0"/>
-                <a:ea typeface="LINE Seed Sans TH Heavy" pitchFamily="34" charset="-122"/>
-                <a:cs typeface="LINE Seed Sans TH Heavy" pitchFamily="34" charset="-120"/>
+                <a:latin typeface="LINE Seed Sans TH" pitchFamily="34" charset="0"/>
+                <a:ea typeface="LINE Seed Sans TH" pitchFamily="34" charset="-122"/>
+                <a:cs typeface="LINE Seed Sans TH" pitchFamily="34" charset="-120"/>
               </a:rPr>
-              <a:t>อยากทำคลิปขายเป็นไหม?</a:t>
+              <a:t>ตัดเองมันเมื่อยมือ !!!</a:t>
             </a:r>
             <a:endParaRPr lang="en-US" sz="4950" dirty="0"/>
           </a:p>
@@ -1033,7 +1033,7 @@
         </p:nvSpPr>
         <p:spPr>
           <a:xfrm>
-            <a:off x="0" y="3733800"/>
+            <a:off x="0" y="3543300"/>
             <a:ext cx="10287000" cy="2305050"/>
           </a:xfrm>
           <a:prstGeom prst="rect">
@@ -1080,7 +1080,7 @@
         </p:blipFill>
         <p:spPr>
           <a:xfrm>
-            <a:off x="8220075" y="2886075"/>
+            <a:off x="8010525" y="2238375"/>
             <a:ext cx="1809750" cy="1809750"/>
           </a:xfrm>
           <a:prstGeom prst="rect">
@@ -1104,8 +1104,8 @@
         </p:blipFill>
         <p:spPr>
           <a:xfrm>
-            <a:off x="0" y="3981450"/>
-            <a:ext cx="4048125" cy="6562725"/>
+            <a:off x="0" y="3324225"/>
+            <a:ext cx="4133850" cy="7534275"/>
           </a:xfrm>
           <a:prstGeom prst="rect">
             <a:avLst/>
@@ -1128,8 +1128,8 @@
         </p:blipFill>
         <p:spPr>
           <a:xfrm>
-            <a:off x="6867525" y="4324350"/>
-            <a:ext cx="3419475" cy="6705600"/>
+            <a:off x="6838950" y="3752850"/>
+            <a:ext cx="3448050" cy="7048500"/>
           </a:xfrm>
           <a:prstGeom prst="rect">
             <a:avLst/>
@@ -1160,9 +1160,147 @@
           </a:prstGeom>
         </p:spPr>
       </p:pic>
+      <p:sp>
+        <p:nvSpPr>
+          <p:cNvPr id="11" name="Name น้องเกรท"/>
+          <p:cNvSpPr txBox="1"/>
+          <p:nvPr/>
+        </p:nvSpPr>
+        <p:spPr>
+          <a:xfrm>
+            <a:off x="38100" y="9525000"/>
+            <a:ext cx="1619250" cy="481905"/>
+          </a:xfrm>
+          <a:prstGeom prst="rect">
+            <a:avLst/>
+          </a:prstGeom>
+          <a:noFill/>
+          <a:ln/>
+          <a:effectLst>
+            <a:outerShdw sx="100000" sy="100000" kx="0" ky="0" algn="bl" rotWithShape="0" blurRad="127000" dist="25400" dir="5400000">
+              <a:srgbClr val="000000">
+                <a:alpha val="60000"/>
+              </a:srgbClr>
+            </a:outerShdw>
+          </a:effectLst>
+        </p:spPr>
+        <p:txBody>
+          <a:bodyPr wrap="square" lIns="0" tIns="0" rIns="0" bIns="0" rtlCol="0" anchor="ctr"/>
+          <a:lstStyle/>
+          <a:p>
+            <a:pPr algn="ctr" indent="0" marL="0">
+              <a:lnSpc>
+                <a:spcPct val="95000"/>
+              </a:lnSpc>
+              <a:buNone/>
+            </a:pPr>
+            <a:r>
+              <a:rPr lang="en-US" sz="1650" b="1" dirty="0">
+                <a:solidFill>
+                  <a:srgbClr val="FFFFFF"/>
+                </a:solidFill>
+                <a:latin typeface="LINE Seed Sans TH" pitchFamily="34" charset="0"/>
+                <a:ea typeface="LINE Seed Sans TH" pitchFamily="34" charset="-122"/>
+                <a:cs typeface="LINE Seed Sans TH" pitchFamily="34" charset="-120"/>
+              </a:rPr>
+              <a:t>น้องเกรท</a:t>
+            </a:r>
+            <a:endParaRPr lang="en-US" sz="1650" dirty="0"/>
+          </a:p>
+          <a:p>
+            <a:pPr algn="ctr" indent="0" marL="0">
+              <a:lnSpc>
+                <a:spcPct val="95000"/>
+              </a:lnSpc>
+              <a:buNone/>
+            </a:pPr>
+            <a:r>
+              <a:rPr lang="en-US" sz="1650" b="1" dirty="0">
+                <a:solidFill>
+                  <a:srgbClr val="FFFFFF"/>
+                </a:solidFill>
+                <a:latin typeface="LINE Seed Sans TH" pitchFamily="34" charset="0"/>
+                <a:ea typeface="LINE Seed Sans TH" pitchFamily="34" charset="-122"/>
+                <a:cs typeface="LINE Seed Sans TH" pitchFamily="34" charset="-120"/>
+              </a:rPr>
+              <a:t>ToGreater</a:t>
+            </a:r>
+            <a:endParaRPr lang="en-US" sz="1650" dirty="0"/>
+          </a:p>
+        </p:txBody>
+      </p:sp>
+      <p:sp>
+        <p:nvSpPr>
+          <p:cNvPr id="12" name="Name พี่มิค"/>
+          <p:cNvSpPr txBox="1"/>
+          <p:nvPr/>
+        </p:nvSpPr>
+        <p:spPr>
+          <a:xfrm>
+            <a:off x="8715375" y="9906000"/>
+            <a:ext cx="1524000" cy="481905"/>
+          </a:xfrm>
+          <a:prstGeom prst="rect">
+            <a:avLst/>
+          </a:prstGeom>
+          <a:noFill/>
+          <a:ln/>
+          <a:effectLst>
+            <a:outerShdw sx="100000" sy="100000" kx="0" ky="0" algn="bl" rotWithShape="0" blurRad="127000" dist="25400" dir="5400000">
+              <a:srgbClr val="000000">
+                <a:alpha val="60000"/>
+              </a:srgbClr>
+            </a:outerShdw>
+          </a:effectLst>
+        </p:spPr>
+        <p:txBody>
+          <a:bodyPr wrap="square" lIns="0" tIns="0" rIns="0" bIns="0" rtlCol="0" anchor="ctr"/>
+          <a:lstStyle/>
+          <a:p>
+            <a:pPr algn="ctr" indent="0" marL="0">
+              <a:lnSpc>
+                <a:spcPct val="95000"/>
+              </a:lnSpc>
+              <a:buNone/>
+            </a:pPr>
+            <a:r>
+              <a:rPr lang="en-US" sz="1650" b="1" dirty="0">
+                <a:solidFill>
+                  <a:srgbClr val="FFFFFF"/>
+                </a:solidFill>
+                <a:latin typeface="LINE Seed Sans TH" pitchFamily="34" charset="0"/>
+                <a:ea typeface="LINE Seed Sans TH" pitchFamily="34" charset="-122"/>
+                <a:cs typeface="LINE Seed Sans TH" pitchFamily="34" charset="-120"/>
+              </a:rPr>
+              <a:t>พี่มิค</a:t>
+            </a:r>
+            <a:endParaRPr lang="en-US" sz="1650" dirty="0"/>
+          </a:p>
+          <a:p>
+            <a:pPr algn="ctr" indent="0" marL="0">
+              <a:lnSpc>
+                <a:spcPct val="95000"/>
+              </a:lnSpc>
+              <a:buNone/>
+            </a:pPr>
+            <a:r>
+              <a:rPr lang="en-US" sz="1650" b="1" dirty="0">
+                <a:solidFill>
+                  <a:srgbClr val="FFFFFF"/>
+                </a:solidFill>
+                <a:latin typeface="LINE Seed Sans TH" pitchFamily="34" charset="0"/>
+                <a:ea typeface="LINE Seed Sans TH" pitchFamily="34" charset="-122"/>
+                <a:cs typeface="LINE Seed Sans TH" pitchFamily="34" charset="-120"/>
+              </a:rPr>
+              <a:t>AI ง่ายง่าย</a:t>
+            </a:r>
+            <a:endParaRPr lang="en-US" sz="1650" dirty="0"/>
+          </a:p>
+        </p:txBody>
+      </p:sp>
       <p:pic>
         <p:nvPicPr>
-          <p:cNvPr id="11" name="Sticker CapCut" descr="/home/user/dsme-2026/poster/pptx-assets-v5/stCapcut.png">    </p:cNvPr>
+          <p:cNvPr id="13" name="Sticker CapCut" descr="/home/user/dsme-2026/poster/pptx-assets-v5/stCapcut.png">    </p:cNvPr>
           <p:cNvPicPr>
             <a:picLocks noChangeAspect="1"/>
           </p:cNvPicPr>
@@ -1186,7 +1324,7 @@
       </p:pic>
       <p:pic>
         <p:nvPicPr>
-          <p:cNvPr id="12" name="Sticker cat" descr="/home/user/dsme-2026/poster/pptx-assets-v5/stCat.png">    </p:cNvPr>
+          <p:cNvPr id="14" name="Sticker cat" descr="/home/user/dsme-2026/poster/pptx-assets-v5/stCat.png">    </p:cNvPr>
           <p:cNvPicPr>
             <a:picLocks noChangeAspect="1"/>
           </p:cNvPicPr>
@@ -1200,8 +1338,8 @@
         </p:blipFill>
         <p:spPr>
           <a:xfrm>
-            <a:off x="723900" y="8963025"/>
-            <a:ext cx="2171700" cy="2171700"/>
+            <a:off x="600075" y="9982200"/>
+            <a:ext cx="1943100" cy="1943100"/>
           </a:xfrm>
           <a:prstGeom prst="rect">
             <a:avLst/>
@@ -1210,7 +1348,7 @@
       </p:pic>
       <p:sp>
         <p:nvSpPr>
-          <p:cNvPr id="13" name="Copy 1"/>
+          <p:cNvPr id="15" name="Copy 1"/>
           <p:cNvSpPr txBox="1"/>
           <p:nvPr/>
         </p:nvSpPr>
@@ -1233,7 +1371,7 @@
               <a:buNone/>
             </a:pPr>
             <a:r>
-              <a:rPr lang="en-US" sz="2400" b="1" i="1" dirty="0">
+              <a:rPr lang="en-US" sz="2400" b="1" dirty="0">
                 <a:solidFill>
                   <a:srgbClr val="FFFFFF"/>
                 </a:solidFill>
@@ -1247,7 +1385,7 @@
               <a:buNone/>
             </a:pPr>
             <a:r>
-              <a:rPr lang="en-US" sz="2400" b="1" i="1" dirty="0">
+              <a:rPr lang="en-US" sz="2400" b="1" dirty="0">
                 <a:solidFill>
                   <a:srgbClr val="FF7A3D"/>
                 </a:solidFill>
@@ -1263,7 +1401,7 @@
       </p:sp>
       <p:sp>
         <p:nvSpPr>
-          <p:cNvPr id="14" name="Copy 2"/>
+          <p:cNvPr id="16" name="Copy 2"/>
           <p:cNvSpPr txBox="1"/>
           <p:nvPr/>
         </p:nvSpPr>
@@ -1286,7 +1424,7 @@
               <a:buNone/>
             </a:pPr>
             <a:r>
-              <a:rPr lang="en-US" sz="2250" i="1" dirty="0">
+              <a:rPr lang="en-US" sz="2250" dirty="0">
                 <a:solidFill>
                   <a:srgbClr val="C7D2FE"/>
                 </a:solidFill>
@@ -1302,14 +1440,14 @@
       </p:sp>
       <p:sp>
         <p:nvSpPr>
-          <p:cNvPr id="15" name="Copy 3"/>
+          <p:cNvPr id="17" name="Copy 3"/>
           <p:cNvSpPr txBox="1"/>
           <p:nvPr/>
         </p:nvSpPr>
         <p:spPr>
           <a:xfrm>
-            <a:off x="1582341" y="11982450"/>
-            <a:ext cx="7122170" cy="533400"/>
+            <a:off x="1543645" y="11982450"/>
+            <a:ext cx="7199561" cy="533400"/>
           </a:xfrm>
           <a:prstGeom prst="rect">
             <a:avLst/>
@@ -1327,7 +1465,7 @@
               <a:buNone/>
             </a:pPr>
             <a:r>
-              <a:rPr lang="en-US" sz="2100" b="1" i="1" dirty="0">
+              <a:rPr lang="en-US" sz="2100" b="1" dirty="0">
                 <a:solidFill>
                   <a:srgbClr val="FFFFFF"/>
                 </a:solidFill>
@@ -1335,13 +1473,13 @@
                 <a:ea typeface="LINE Seed Sans TH" pitchFamily="34" charset="-122"/>
                 <a:cs typeface="LINE Seed Sans TH" pitchFamily="34" charset="-120"/>
               </a:rPr>
-              <a:t>เสาร์ 7 พ.ย. 69 · รับ 10 ที่นั่ง · รอบแรก 6,990.- </a:t>
+              <a:t>เสาร์ 7 พ.ย. 69 · รับ 10 ที่นั่ง · รอบแรก 9,900.- </a:t>
             </a:r>
             <a:pPr algn="ctr" indent="0" marL="0">
               <a:buNone/>
             </a:pPr>
             <a:r>
-              <a:rPr lang="en-US" sz="2100" b="1" i="1" strike="sngStrike" dirty="0">
+              <a:rPr lang="en-US" sz="2100" b="1" strike="sngStrike" dirty="0">
                 <a:solidFill>
                   <a:srgbClr val="FFFFFF"/>
                 </a:solidFill>
@@ -1349,7 +1487,7 @@
                 <a:ea typeface="LINE Seed Sans TH" pitchFamily="34" charset="-122"/>
                 <a:cs typeface="LINE Seed Sans TH" pitchFamily="34" charset="-120"/>
               </a:rPr>
-              <a:t>(ปกติ 8,500)</a:t>
+              <a:t>(ปกติ 12,900)</a:t>
             </a:r>
             <a:endParaRPr lang="en-US" sz="2100" dirty="0"/>
           </a:p>

</xml_diff>

<commit_message>
v5: bigger price block, show Great's full hair and longer neck
Co-Authored-By: Claude Opus 5.5 <noreply@anthropic.com>
Claude-Session: https://claude.ai/code/session_01AU6SJgpQqjx92uQU48rYBV
</commit_message>
<xml_diff>
--- a/poster/ai-capcut-1day-v5.pptx
+++ b/poster/ai-capcut-1day-v5.pptx
@@ -1104,8 +1104,8 @@
         </p:blipFill>
         <p:spPr>
           <a:xfrm>
-            <a:off x="0" y="3324225"/>
-            <a:ext cx="4133850" cy="7534275"/>
+            <a:off x="0" y="3724275"/>
+            <a:ext cx="3952875" cy="6524625"/>
           </a:xfrm>
           <a:prstGeom prst="rect">
             <a:avLst/>
@@ -1152,8 +1152,8 @@
         </p:blipFill>
         <p:spPr>
           <a:xfrm>
-            <a:off x="1571625" y="5238750"/>
-            <a:ext cx="7143750" cy="5391150"/>
+            <a:off x="1924050" y="5238750"/>
+            <a:ext cx="6762750" cy="5391150"/>
           </a:xfrm>
           <a:prstGeom prst="rect">
             <a:avLst/>
@@ -1338,8 +1338,8 @@
         </p:blipFill>
         <p:spPr>
           <a:xfrm>
-            <a:off x="600075" y="9982200"/>
-            <a:ext cx="1943100" cy="1943100"/>
+            <a:off x="276225" y="10563225"/>
+            <a:ext cx="1905000" cy="1905000"/>
           </a:xfrm>
           <a:prstGeom prst="rect">
             <a:avLst/>
@@ -1354,7 +1354,7 @@
         </p:nvSpPr>
         <p:spPr>
           <a:xfrm>
-            <a:off x="0" y="10858500"/>
+            <a:off x="0" y="10458450"/>
             <a:ext cx="10287000" cy="485775"/>
           </a:xfrm>
           <a:prstGeom prst="rect">
@@ -1401,14 +1401,14 @@
       </p:sp>
       <p:sp>
         <p:nvSpPr>
-          <p:cNvPr id="16" name="Copy 2"/>
+          <p:cNvPr id="16" name="Price label"/>
           <p:cNvSpPr txBox="1"/>
           <p:nvPr/>
         </p:nvSpPr>
         <p:spPr>
           <a:xfrm>
-            <a:off x="0" y="11401425"/>
-            <a:ext cx="10287000" cy="447675"/>
+            <a:off x="2394942" y="11286083"/>
+            <a:ext cx="1661815" cy="619125"/>
           </a:xfrm>
           <a:prstGeom prst="rect">
             <a:avLst/>
@@ -1420,11 +1420,11 @@
           <a:bodyPr wrap="square" lIns="0" tIns="0" rIns="0" bIns="0" rtlCol="0" anchor="ctr"/>
           <a:lstStyle/>
           <a:p>
-            <a:pPr algn="ctr" indent="0" marL="0">
+            <a:pPr algn="r" indent="0" marL="0">
               <a:buNone/>
             </a:pPr>
             <a:r>
-              <a:rPr lang="en-US" sz="2250" dirty="0">
+              <a:rPr lang="en-US" sz="1950" b="1" dirty="0">
                 <a:solidFill>
                   <a:srgbClr val="C7D2FE"/>
                 </a:solidFill>
@@ -1432,22 +1432,99 @@
                 <a:ea typeface="LINE Seed Sans TH" pitchFamily="34" charset="-122"/>
                 <a:cs typeface="LINE Seed Sans TH" pitchFamily="34" charset="-120"/>
               </a:rPr>
-              <a:t>คอร์สสด 1 วันจบ · สนใจ คอมเมนต์เลย!</a:t>
-            </a:r>
-            <a:endParaRPr lang="en-US" sz="2250" dirty="0"/>
+              <a:t>ราคารอบแรก</a:t>
+            </a:r>
+            <a:endParaRPr lang="en-US" sz="1950" dirty="0"/>
+          </a:p>
+          <a:p>
+            <a:pPr algn="r" indent="0" marL="0">
+              <a:buNone/>
+            </a:pPr>
+            <a:r>
+              <a:rPr lang="en-US" sz="1950" strike="sngStrike" dirty="0">
+                <a:solidFill>
+                  <a:srgbClr val="94A3B8"/>
+                </a:solidFill>
+                <a:latin typeface="LINE Seed Sans TH" pitchFamily="34" charset="0"/>
+                <a:ea typeface="LINE Seed Sans TH" pitchFamily="34" charset="-122"/>
+                <a:cs typeface="LINE Seed Sans TH" pitchFamily="34" charset="-120"/>
+              </a:rPr>
+              <a:t>ปกติ 12,900</a:t>
+            </a:r>
+            <a:endParaRPr lang="en-US" sz="1950" dirty="0"/>
           </a:p>
         </p:txBody>
       </p:sp>
       <p:sp>
         <p:nvSpPr>
-          <p:cNvPr id="17" name="Copy 3"/>
+          <p:cNvPr id="17" name="Price"/>
           <p:cNvSpPr txBox="1"/>
           <p:nvPr/>
         </p:nvSpPr>
         <p:spPr>
           <a:xfrm>
-            <a:off x="1543645" y="11982450"/>
-            <a:ext cx="7199561" cy="533400"/>
+            <a:off x="4247257" y="10982325"/>
+            <a:ext cx="3740051" cy="1226790"/>
+          </a:xfrm>
+          <a:prstGeom prst="rect">
+            <a:avLst/>
+          </a:prstGeom>
+          <a:noFill/>
+          <a:ln/>
+          <a:effectLst>
+            <a:outerShdw sx="100000" sy="100000" kx="0" ky="0" algn="bl" rotWithShape="0" blurRad="304800" dist="101600" dir="5400000">
+              <a:srgbClr val="FF7A3D">
+                <a:alpha val="35000"/>
+              </a:srgbClr>
+            </a:outerShdw>
+          </a:effectLst>
+        </p:spPr>
+        <p:txBody>
+          <a:bodyPr wrap="square" lIns="0" tIns="0" rIns="0" bIns="0" rtlCol="0" anchor="ctr"/>
+          <a:lstStyle/>
+          <a:p>
+            <a:pPr algn="l" indent="0" marL="0">
+              <a:buNone/>
+            </a:pPr>
+            <a:r>
+              <a:rPr lang="en-US" sz="8400" dirty="0">
+                <a:solidFill>
+                  <a:srgbClr val="FF7A3D"/>
+                </a:solidFill>
+                <a:latin typeface="LINE Seed Sans TH Heavy" pitchFamily="34" charset="0"/>
+                <a:ea typeface="LINE Seed Sans TH Heavy" pitchFamily="34" charset="-122"/>
+                <a:cs typeface="LINE Seed Sans TH Heavy" pitchFamily="34" charset="-120"/>
+              </a:rPr>
+              <a:t>9,900</a:t>
+            </a:r>
+            <a:pPr algn="l" indent="0" marL="0">
+              <a:buNone/>
+            </a:pPr>
+            <a:r>
+              <a:rPr lang="en-US" sz="3300" dirty="0">
+                <a:solidFill>
+                  <a:srgbClr val="FF7A3D"/>
+                </a:solidFill>
+                <a:latin typeface="LINE Seed Sans TH Heavy" pitchFamily="34" charset="0"/>
+                <a:ea typeface="LINE Seed Sans TH Heavy" pitchFamily="34" charset="-122"/>
+                <a:cs typeface="LINE Seed Sans TH Heavy" pitchFamily="34" charset="-120"/>
+              </a:rPr>
+              <a:t>.-</a:t>
+            </a:r>
+            <a:endParaRPr lang="en-US" sz="8400" dirty="0"/>
+          </a:p>
+        </p:txBody>
+      </p:sp>
+      <p:sp>
+        <p:nvSpPr>
+          <p:cNvPr id="18" name="Info bar"/>
+          <p:cNvSpPr txBox="1"/>
+          <p:nvPr/>
+        </p:nvSpPr>
+        <p:spPr>
+          <a:xfrm>
+            <a:off x="1161306" y="12228165"/>
+            <a:ext cx="7964388" cy="533400"/>
           </a:xfrm>
           <a:prstGeom prst="rect">
             <a:avLst/>
@@ -1473,21 +1550,7 @@
                 <a:ea typeface="LINE Seed Sans TH" pitchFamily="34" charset="-122"/>
                 <a:cs typeface="LINE Seed Sans TH" pitchFamily="34" charset="-120"/>
               </a:rPr>
-              <a:t>เสาร์ 7 พ.ย. 69 · รับ 10 ที่นั่ง · รอบแรก 9,900.- </a:t>
-            </a:r>
-            <a:pPr algn="ctr" indent="0" marL="0">
-              <a:buNone/>
-            </a:pPr>
-            <a:r>
-              <a:rPr lang="en-US" sz="2100" b="1" strike="sngStrike" dirty="0">
-                <a:solidFill>
-                  <a:srgbClr val="FFFFFF"/>
-                </a:solidFill>
-                <a:latin typeface="LINE Seed Sans TH" pitchFamily="34" charset="0"/>
-                <a:ea typeface="LINE Seed Sans TH" pitchFamily="34" charset="-122"/>
-                <a:cs typeface="LINE Seed Sans TH" pitchFamily="34" charset="-120"/>
-              </a:rPr>
-              <a:t>(ปกติ 12,900)</a:t>
+              <a:t>คอร์สสด 1 วันจบ · เสาร์ 7 พ.ย. 69 · รับ 10 ที่นั่ง · สนใจ คอมเมนต์เลย!</a:t>
             </a:r>
             <a:endParaRPr lang="en-US" sz="2100" dirty="0"/>
           </a:p>

</xml_diff>